<commit_message>
Actualizar guiones de video y mejorar contenido de lógica difusa en la presentación
</commit_message>
<xml_diff>
--- a/Plantilla Tutoriales UNAL V2.pptx
+++ b/Plantilla Tutoriales UNAL V2.pptx
@@ -231,7 +231,7 @@
             <a:fld id="{4E2C0401-C547-6B40-906F-0A178EDB9A24}" type="datetimeFigureOut">
               <a:rPr lang="es-ES_tradnl" smtClean="0"/>
               <a:pPr/>
-              <a:t>28/05/2026</a:t>
+              <a:t>8/6/26</a:t>
             </a:fld>
             <a:endParaRPr lang="en-GB"/>
           </a:p>
@@ -1739,7 +1739,7 @@
             <a:fld id="{F211D454-A893-5E4D-9D8B-185D411D2F66}" type="datetimeFigureOut">
               <a:rPr lang="es-ES_tradnl" smtClean="0"/>
               <a:pPr/>
-              <a:t>28/05/2026</a:t>
+              <a:t>8/6/26</a:t>
             </a:fld>
             <a:endParaRPr lang="en-GB"/>
           </a:p>
@@ -2027,7 +2027,7 @@
             <a:fld id="{F211D454-A893-5E4D-9D8B-185D411D2F66}" type="datetimeFigureOut">
               <a:rPr lang="es-ES_tradnl" smtClean="0"/>
               <a:pPr/>
-              <a:t>28/05/2026</a:t>
+              <a:t>8/6/26</a:t>
             </a:fld>
             <a:endParaRPr lang="en-GB"/>
           </a:p>
@@ -2451,7 +2451,7 @@
             <a:fld id="{F211D454-A893-5E4D-9D8B-185D411D2F66}" type="datetimeFigureOut">
               <a:rPr lang="es-ES_tradnl" smtClean="0"/>
               <a:pPr/>
-              <a:t>28/05/2026</a:t>
+              <a:t>8/6/26</a:t>
             </a:fld>
             <a:endParaRPr lang="en-GB"/>
           </a:p>
@@ -2870,7 +2870,7 @@
             <a:fld id="{F211D454-A893-5E4D-9D8B-185D411D2F66}" type="datetimeFigureOut">
               <a:rPr lang="es-ES_tradnl" smtClean="0"/>
               <a:pPr/>
-              <a:t>28/05/2026</a:t>
+              <a:t>8/6/26</a:t>
             </a:fld>
             <a:endParaRPr lang="en-GB"/>
           </a:p>
@@ -3005,7 +3005,7 @@
             <a:fld id="{F211D454-A893-5E4D-9D8B-185D411D2F66}" type="datetimeFigureOut">
               <a:rPr lang="es-ES_tradnl" smtClean="0"/>
               <a:pPr/>
-              <a:t>28/05/2026</a:t>
+              <a:t>8/6/26</a:t>
             </a:fld>
             <a:endParaRPr lang="en-GB"/>
           </a:p>
@@ -3326,7 +3326,7 @@
             <a:fld id="{F211D454-A893-5E4D-9D8B-185D411D2F66}" type="datetimeFigureOut">
               <a:rPr lang="es-ES_tradnl" smtClean="0"/>
               <a:pPr/>
-              <a:t>28/05/2026</a:t>
+              <a:t>8/6/26</a:t>
             </a:fld>
             <a:endParaRPr lang="en-GB"/>
           </a:p>
@@ -3569,7 +3569,7 @@
             <a:fld id="{F211D454-A893-5E4D-9D8B-185D411D2F66}" type="datetimeFigureOut">
               <a:rPr lang="es-ES_tradnl" smtClean="0"/>
               <a:pPr/>
-              <a:t>28/05/2026</a:t>
+              <a:t>8/6/26</a:t>
             </a:fld>
             <a:endParaRPr lang="en-GB"/>
           </a:p>
@@ -3906,7 +3906,7 @@
             <a:fld id="{F211D454-A893-5E4D-9D8B-185D411D2F66}" type="datetimeFigureOut">
               <a:rPr lang="es-ES_tradnl" smtClean="0"/>
               <a:pPr/>
-              <a:t>28/05/2026</a:t>
+              <a:t>8/6/26</a:t>
             </a:fld>
             <a:endParaRPr lang="en-GB"/>
           </a:p>
@@ -4205,7 +4205,7 @@
             <a:fld id="{F211D454-A893-5E4D-9D8B-185D411D2F66}" type="datetimeFigureOut">
               <a:rPr lang="es-ES_tradnl" smtClean="0"/>
               <a:pPr/>
-              <a:t>28/05/2026</a:t>
+              <a:t>8/6/26</a:t>
             </a:fld>
             <a:endParaRPr lang="en-GB"/>
           </a:p>
@@ -4610,7 +4610,7 @@
             <a:fld id="{F211D454-A893-5E4D-9D8B-185D411D2F66}" type="datetimeFigureOut">
               <a:rPr lang="es-ES_tradnl" smtClean="0"/>
               <a:pPr/>
-              <a:t>28/05/2026</a:t>
+              <a:t>8/6/26</a:t>
             </a:fld>
             <a:endParaRPr lang="en-GB"/>
           </a:p>
@@ -4830,7 +4830,7 @@
             <a:fld id="{F211D454-A893-5E4D-9D8B-185D411D2F66}" type="datetimeFigureOut">
               <a:rPr lang="es-ES_tradnl" smtClean="0"/>
               <a:pPr/>
-              <a:t>28/05/2026</a:t>
+              <a:t>8/6/26</a:t>
             </a:fld>
             <a:endParaRPr lang="en-GB"/>
           </a:p>
@@ -5002,7 +5002,7 @@
             <a:fld id="{F211D454-A893-5E4D-9D8B-185D411D2F66}" type="datetimeFigureOut">
               <a:rPr lang="es-ES_tradnl" smtClean="0"/>
               <a:pPr/>
-              <a:t>28/05/2026</a:t>
+              <a:t>8/6/26</a:t>
             </a:fld>
             <a:endParaRPr lang="en-GB"/>
           </a:p>
@@ -5549,7 +5549,7 @@
             <a:fld id="{F211D454-A893-5E4D-9D8B-185D411D2F66}" type="datetimeFigureOut">
               <a:rPr lang="es-ES_tradnl" smtClean="0"/>
               <a:pPr/>
-              <a:t>28/05/2026</a:t>
+              <a:t>8/6/26</a:t>
             </a:fld>
             <a:endParaRPr lang="en-GB"/>
           </a:p>
@@ -5874,7 +5874,7 @@
             <a:fld id="{F211D454-A893-5E4D-9D8B-185D411D2F66}" type="datetimeFigureOut">
               <a:rPr lang="es-ES_tradnl" smtClean="0"/>
               <a:pPr/>
-              <a:t>28/05/2026</a:t>
+              <a:t>8/6/26</a:t>
             </a:fld>
             <a:endParaRPr lang="en-GB"/>
           </a:p>
@@ -6208,7 +6208,7 @@
             <a:fld id="{F211D454-A893-5E4D-9D8B-185D411D2F66}" type="datetimeFigureOut">
               <a:rPr lang="es-ES_tradnl" smtClean="0"/>
               <a:pPr/>
-              <a:t>28/05/2026</a:t>
+              <a:t>8/6/26</a:t>
             </a:fld>
             <a:endParaRPr lang="en-GB"/>
           </a:p>
@@ -6831,7 +6831,7 @@
             <a:fld id="{F211D454-A893-5E4D-9D8B-185D411D2F66}" type="datetimeFigureOut">
               <a:rPr lang="es-ES_tradnl" smtClean="0"/>
               <a:pPr/>
-              <a:t>28/05/2026</a:t>
+              <a:t>8/6/26</a:t>
             </a:fld>
             <a:endParaRPr lang="en-GB"/>
           </a:p>
@@ -7320,7 +7320,7 @@
             <a:fld id="{F211D454-A893-5E4D-9D8B-185D411D2F66}" type="datetimeFigureOut">
               <a:rPr lang="es-ES_tradnl" smtClean="0"/>
               <a:pPr/>
-              <a:t>28/05/2026</a:t>
+              <a:t>8/6/26</a:t>
             </a:fld>
             <a:endParaRPr lang="en-GB"/>
           </a:p>
@@ -7570,7 +7570,7 @@
             <a:fld id="{F211D454-A893-5E4D-9D8B-185D411D2F66}" type="datetimeFigureOut">
               <a:rPr lang="es-ES_tradnl" smtClean="0"/>
               <a:pPr/>
-              <a:t>28/05/2026</a:t>
+              <a:t>8/6/26</a:t>
             </a:fld>
             <a:endParaRPr lang="en-GB"/>
           </a:p>
@@ -7868,7 +7868,7 @@
             <a:fld id="{F211D454-A893-5E4D-9D8B-185D411D2F66}" type="datetimeFigureOut">
               <a:rPr lang="es-ES_tradnl" smtClean="0"/>
               <a:pPr/>
-              <a:t>28/05/2026</a:t>
+              <a:t>8/6/26</a:t>
             </a:fld>
             <a:endParaRPr lang="en-GB"/>
           </a:p>
@@ -8348,7 +8348,7 @@
         <p:spPr/>
         <p:txBody>
           <a:bodyPr>
-            <a:normAutofit/>
+            <a:normAutofit fontScale="92500" lnSpcReduction="20000"/>
           </a:bodyPr>
           <a:lstStyle/>
           <a:p>
@@ -8358,15 +8358,92 @@
                   <a:schemeClr val="accent1"/>
                 </a:solidFill>
               </a:rPr>
-              <a:t>Nombres, apellidos, correo por cada estudiante</a:t>
-            </a:r>
-          </a:p>
-          <a:p>
-            <a:endParaRPr lang="es-ES_tradnl" sz="1400" dirty="0">
-              <a:solidFill>
-                <a:srgbClr val="000000"/>
-              </a:solidFill>
-            </a:endParaRPr>
+              <a:t>- Sebastián Valencia Carvajal (</a:t>
+            </a:r>
+            <a:r>
+              <a:rPr lang="es-ES_tradnl" sz="1400" b="1" dirty="0" err="1">
+                <a:solidFill>
+                  <a:schemeClr val="accent1"/>
+                </a:solidFill>
+              </a:rPr>
+              <a:t>sevalenciaca@unal.edu.co</a:t>
+            </a:r>
+            <a:r>
+              <a:rPr lang="es-ES_tradnl" sz="1400" b="1" dirty="0">
+                <a:solidFill>
+                  <a:schemeClr val="accent1"/>
+                </a:solidFill>
+              </a:rPr>
+              <a:t>)</a:t>
+            </a:r>
+          </a:p>
+          <a:p>
+            <a:r>
+              <a:rPr lang="es-ES_tradnl" sz="1400" b="1" dirty="0">
+                <a:solidFill>
+                  <a:schemeClr val="accent1"/>
+                </a:solidFill>
+              </a:rPr>
+              <a:t>- Daniel </a:t>
+            </a:r>
+            <a:r>
+              <a:rPr lang="es-ES_tradnl" sz="1400" b="1" dirty="0" err="1">
+                <a:solidFill>
+                  <a:schemeClr val="accent1"/>
+                </a:solidFill>
+              </a:rPr>
+              <a:t>Alzate</a:t>
+            </a:r>
+            <a:r>
+              <a:rPr lang="es-ES_tradnl" sz="1400" b="1" dirty="0">
+                <a:solidFill>
+                  <a:schemeClr val="accent1"/>
+                </a:solidFill>
+              </a:rPr>
+              <a:t> Ocampo (</a:t>
+            </a:r>
+            <a:r>
+              <a:rPr lang="es-ES_tradnl" sz="1400" b="1" dirty="0" err="1">
+                <a:solidFill>
+                  <a:schemeClr val="accent1"/>
+                </a:solidFill>
+              </a:rPr>
+              <a:t>dalzateo@unal.edu.co</a:t>
+            </a:r>
+            <a:r>
+              <a:rPr lang="es-ES_tradnl" sz="1400" b="1" dirty="0">
+                <a:solidFill>
+                  <a:schemeClr val="accent1"/>
+                </a:solidFill>
+              </a:rPr>
+              <a:t>)</a:t>
+            </a:r>
+          </a:p>
+          <a:p>
+            <a:r>
+              <a:rPr lang="es-ES_tradnl" sz="1400" b="1" dirty="0">
+                <a:solidFill>
+                  <a:schemeClr val="accent1"/>
+                </a:solidFill>
+              </a:rPr>
+              <a:t>- Santiago Valencia Saavedra (</a:t>
+            </a:r>
+            <a:r>
+              <a:rPr lang="es-ES_tradnl" sz="1400" b="1" dirty="0" err="1">
+                <a:solidFill>
+                  <a:schemeClr val="accent1"/>
+                </a:solidFill>
+              </a:rPr>
+              <a:t>savalenciasa@unal.edu.co</a:t>
+            </a:r>
+            <a:r>
+              <a:rPr lang="es-ES_tradnl" sz="1400" b="1" dirty="0">
+                <a:solidFill>
+                  <a:schemeClr val="accent1"/>
+                </a:solidFill>
+              </a:rPr>
+              <a:t>)</a:t>
+            </a:r>
           </a:p>
         </p:txBody>
       </p:sp>
@@ -8379,7 +8456,7 @@
         <p:spPr>
           <a:xfrm>
             <a:off x="3535838" y="502410"/>
-            <a:ext cx="5123530" cy="707886"/>
+            <a:ext cx="5123530" cy="3170099"/>
           </a:xfrm>
           <a:prstGeom prst="rect">
             <a:avLst/>
@@ -8399,7 +8476,15 @@
                   <a:srgbClr val="FFFFFF"/>
                 </a:solidFill>
               </a:rPr>
-              <a:t>Tutorial Titulo</a:t>
+              <a:t>Automatización Inteligente de Facturación Electrónica con Agente </a:t>
+            </a:r>
+            <a:r>
+              <a:rPr lang="es-ES" sz="4000" b="1" dirty="0" err="1">
+                <a:solidFill>
+                  <a:srgbClr val="FFFFFF"/>
+                </a:solidFill>
+              </a:rPr>
+              <a:t>LangChain</a:t>
             </a:r>
             <a:endParaRPr lang="es-ES_tradnl" sz="3200" b="1" dirty="0">
               <a:solidFill>
@@ -13148,43 +13233,83 @@
       </p:sp>
       <p:sp>
         <p:nvSpPr>
-          <p:cNvPr id="4" name="Marcador de contenido 2">
+          <p:cNvPr id="3" name="CuadroTexto 2">
             <a:extLst>
               <a:ext uri="{FF2B5EF4-FFF2-40B4-BE49-F238E27FC236}">
-                <a16:creationId xmlns:a16="http://schemas.microsoft.com/office/drawing/2014/main" id="{62988A34-B4DE-78CF-2947-828B5C757C4E}"/>
+                <a16:creationId xmlns:a16="http://schemas.microsoft.com/office/drawing/2014/main" id="{F99325EB-6674-6C04-130B-DD4C258D3852}"/>
               </a:ext>
             </a:extLst>
           </p:cNvPr>
-          <p:cNvSpPr>
-            <a:spLocks noGrp="1"/>
-          </p:cNvSpPr>
-          <p:nvPr>
-            <p:ph idx="1"/>
-          </p:nvPr>
-        </p:nvSpPr>
-        <p:spPr>
-          <a:xfrm>
-            <a:off x="2230581" y="1470818"/>
-            <a:ext cx="6508377" cy="3916363"/>
-          </a:xfrm>
-        </p:spPr>
-        <p:txBody>
-          <a:bodyPr/>
-          <a:lstStyle/>
+          <p:cNvSpPr txBox="1"/>
+          <p:nvPr/>
+        </p:nvSpPr>
+        <p:spPr>
+          <a:xfrm>
+            <a:off x="457200" y="1867213"/>
+            <a:ext cx="8229599" cy="3416320"/>
+          </a:xfrm>
+          <a:prstGeom prst="rect">
+            <a:avLst/>
+          </a:prstGeom>
+          <a:noFill/>
+        </p:spPr>
+        <p:txBody>
+          <a:bodyPr wrap="square" rtlCol="0">
+            <a:spAutoFit/>
+          </a:bodyPr>
+          <a:lstStyle/>
+          <a:p>
+            <a:r>
+              <a:rPr lang="es-CO" b="1" dirty="0"/>
+              <a:t>Problema identificado</a:t>
+            </a:r>
+          </a:p>
           <a:p>
             <a:r>
               <a:rPr lang="es-CO" dirty="0"/>
-              <a:t>Definición</a:t>
-            </a:r>
-          </a:p>
-          <a:p>
+              <a:t>En la empresa </a:t>
+            </a:r>
+            <a:r>
+              <a:rPr lang="es-CO" dirty="0" err="1"/>
+              <a:t>Suprokom</a:t>
+            </a:r>
             <a:r>
               <a:rPr lang="es-CO" dirty="0"/>
-              <a:t>Ejemplo</a:t>
+              <a:t> SAS, la facturación electrónica se recibe vía correo electrónico. Un operario humano debe:</a:t>
+            </a:r>
+          </a:p>
+          <a:p>
+            <a:r>
+              <a:rPr lang="es-CO" dirty="0"/>
+              <a:t>1. Revisar correo por correo manualmente</a:t>
+            </a:r>
+          </a:p>
+          <a:p>
+            <a:r>
+              <a:rPr lang="es-CO" dirty="0"/>
+              <a:t>2. Descargar y descomprimir archivos ZIP adjuntos</a:t>
+            </a:r>
+          </a:p>
+          <a:p>
+            <a:r>
+              <a:rPr lang="es-CO" dirty="0"/>
+              <a:t>3. Abrir el PDF para verificar información</a:t>
+            </a:r>
+          </a:p>
+          <a:p>
+            <a:r>
+              <a:rPr lang="es-CO" dirty="0"/>
+              <a:t>4. Transcribir manualmente los datos (NIT, razón social, monto, fecha) a una hoja de cálculo</a:t>
             </a:r>
           </a:p>
           <a:p>
             <a:endParaRPr lang="es-CO" dirty="0"/>
+          </a:p>
+          <a:p>
+            <a:r>
+              <a:rPr lang="es-CO" dirty="0"/>
+              <a:t>Este proceso es repetitivo, propenso a errores humanos y consume aproximadamente 30 minutos diarios con un volumen promedio de 10 facturas/día.</a:t>
+            </a:r>
           </a:p>
         </p:txBody>
       </p:sp>
@@ -13252,6 +13377,111 @@
             <a:br>
               <a:rPr lang="es-CO" dirty="0"/>
             </a:br>
+            <a:endParaRPr lang="es-CO" dirty="0"/>
+          </a:p>
+        </p:txBody>
+      </p:sp>
+      <p:sp>
+        <p:nvSpPr>
+          <p:cNvPr id="3" name="CuadroTexto 2">
+            <a:extLst>
+              <a:ext uri="{FF2B5EF4-FFF2-40B4-BE49-F238E27FC236}">
+                <a16:creationId xmlns:a16="http://schemas.microsoft.com/office/drawing/2014/main" id="{5C73B321-4C12-F2E0-4E8D-FEEBBA1365D2}"/>
+              </a:ext>
+            </a:extLst>
+          </p:cNvPr>
+          <p:cNvSpPr txBox="1"/>
+          <p:nvPr/>
+        </p:nvSpPr>
+        <p:spPr>
+          <a:xfrm>
+            <a:off x="495757" y="1839817"/>
+            <a:ext cx="7877061" cy="4616648"/>
+          </a:xfrm>
+          <a:prstGeom prst="rect">
+            <a:avLst/>
+          </a:prstGeom>
+          <a:noFill/>
+        </p:spPr>
+        <p:txBody>
+          <a:bodyPr wrap="square" rtlCol="0">
+            <a:spAutoFit/>
+          </a:bodyPr>
+          <a:lstStyle/>
+          <a:p>
+            <a:r>
+              <a:rPr lang="es-CO" b="1" dirty="0"/>
+              <a:t>Propuesta de solución</a:t>
+            </a:r>
+          </a:p>
+          <a:p>
+            <a:r>
+              <a:rPr lang="es-CO" dirty="0"/>
+              <a:t>Desarrollar un sistema inteligente que automatice completamente este flujo:</a:t>
+            </a:r>
+          </a:p>
+          <a:p>
+            <a:r>
+              <a:rPr lang="es-CO" dirty="0"/>
+              <a:t>- Lectura automática de correos no leídos vía IMAP</a:t>
+            </a:r>
+          </a:p>
+          <a:p>
+            <a:r>
+              <a:rPr lang="es-CO" dirty="0"/>
+              <a:t>- Extracción y descompresión de archivos adjuntos (ZIP → PDF + XML)</a:t>
+            </a:r>
+          </a:p>
+          <a:p>
+            <a:r>
+              <a:rPr lang="es-CO" dirty="0"/>
+              <a:t>- </a:t>
+            </a:r>
+            <a:r>
+              <a:rPr lang="es-CO" dirty="0" err="1"/>
+              <a:t>Parseo</a:t>
+            </a:r>
+            <a:r>
+              <a:rPr lang="es-CO" dirty="0"/>
+              <a:t> estructurado del XML de factura electrónica colombiana (UBL 2.1)</a:t>
+            </a:r>
+          </a:p>
+          <a:p>
+            <a:r>
+              <a:rPr lang="es-CO" dirty="0"/>
+              <a:t>- Registro automático de datos en tabla/hoja de cálculo</a:t>
+            </a:r>
+          </a:p>
+          <a:p>
+            <a:r>
+              <a:rPr lang="es-CO" dirty="0"/>
+              <a:t>- Priorización inteligente de pagos mediante lógica difusa</a:t>
+            </a:r>
+          </a:p>
+          <a:p>
+            <a:endParaRPr lang="es-CO" dirty="0"/>
+          </a:p>
+          <a:p>
+            <a:r>
+              <a:rPr lang="es-CO" b="1" dirty="0"/>
+              <a:t>Relevancia académica</a:t>
+            </a:r>
+          </a:p>
+          <a:p>
+            <a:r>
+              <a:rPr lang="es-CO" dirty="0"/>
+              <a:t>El proyecto integra conceptos de agentes inteligentes (</a:t>
+            </a:r>
+            <a:r>
+              <a:rPr lang="es-CO" dirty="0" err="1"/>
+              <a:t>ReAct</a:t>
+            </a:r>
+            <a:r>
+              <a:rPr lang="es-CO" dirty="0"/>
+              <a:t>), procesamiento de lenguaje natural (GPT-4o), automatización de flujos (N8n) y racionalidad formal (lógica difusa), aplicados a un caso de uso empresarial real.</a:t>
+            </a:r>
+          </a:p>
+          <a:p>
             <a:endParaRPr lang="es-CO" dirty="0"/>
           </a:p>
         </p:txBody>

</xml_diff>